<commit_message>
problem set 4 added, Raschka book chapters added
</commit_message>
<xml_diff>
--- a/lecture_slides/Week4_Lecture7_FIR_Filter_Design_Windowing_Conv1d.pptx
+++ b/lecture_slides/Week4_Lecture7_FIR_Filter_Design_Windowing_Conv1d.pptx
@@ -333,7 +333,7 @@
           <a:p>
             <a:fld id="{5BCAD085-E8A6-8845-BD4E-CB4CCA059FC4}" type="datetimeFigureOut">
               <a:rPr lang="en-US" smtClean="0"/>
-              <a:t>9/9/2026</a:t>
+              <a:t>9/10/2026</a:t>
             </a:fld>
             <a:endParaRPr lang="en-US"/>
           </a:p>
@@ -501,7 +501,7 @@
           <a:p>
             <a:fld id="{5BCAD085-E8A6-8845-BD4E-CB4CCA059FC4}" type="datetimeFigureOut">
               <a:rPr lang="en-US" smtClean="0"/>
-              <a:t>9/9/2026</a:t>
+              <a:t>9/10/2026</a:t>
             </a:fld>
             <a:endParaRPr lang="en-US"/>
           </a:p>
@@ -679,7 +679,7 @@
           <a:p>
             <a:fld id="{5BCAD085-E8A6-8845-BD4E-CB4CCA059FC4}" type="datetimeFigureOut">
               <a:rPr lang="en-US" smtClean="0"/>
-              <a:t>9/9/2026</a:t>
+              <a:t>9/10/2026</a:t>
             </a:fld>
             <a:endParaRPr lang="en-US"/>
           </a:p>
@@ -847,7 +847,7 @@
           <a:p>
             <a:fld id="{5BCAD085-E8A6-8845-BD4E-CB4CCA059FC4}" type="datetimeFigureOut">
               <a:rPr lang="en-US" smtClean="0"/>
-              <a:t>9/9/2026</a:t>
+              <a:t>9/10/2026</a:t>
             </a:fld>
             <a:endParaRPr lang="en-US"/>
           </a:p>
@@ -1092,7 +1092,7 @@
           <a:p>
             <a:fld id="{5BCAD085-E8A6-8845-BD4E-CB4CCA059FC4}" type="datetimeFigureOut">
               <a:rPr lang="en-US" smtClean="0"/>
-              <a:t>9/9/2026</a:t>
+              <a:t>9/10/2026</a:t>
             </a:fld>
             <a:endParaRPr lang="en-US"/>
           </a:p>
@@ -1377,7 +1377,7 @@
           <a:p>
             <a:fld id="{5BCAD085-E8A6-8845-BD4E-CB4CCA059FC4}" type="datetimeFigureOut">
               <a:rPr lang="en-US" smtClean="0"/>
-              <a:t>9/9/2026</a:t>
+              <a:t>9/10/2026</a:t>
             </a:fld>
             <a:endParaRPr lang="en-US"/>
           </a:p>
@@ -1796,7 +1796,7 @@
           <a:p>
             <a:fld id="{5BCAD085-E8A6-8845-BD4E-CB4CCA059FC4}" type="datetimeFigureOut">
               <a:rPr lang="en-US" smtClean="0"/>
-              <a:t>9/9/2026</a:t>
+              <a:t>9/10/2026</a:t>
             </a:fld>
             <a:endParaRPr lang="en-US"/>
           </a:p>
@@ -1913,7 +1913,7 @@
           <a:p>
             <a:fld id="{5BCAD085-E8A6-8845-BD4E-CB4CCA059FC4}" type="datetimeFigureOut">
               <a:rPr lang="en-US" smtClean="0"/>
-              <a:t>9/9/2026</a:t>
+              <a:t>9/10/2026</a:t>
             </a:fld>
             <a:endParaRPr lang="en-US"/>
           </a:p>
@@ -2008,7 +2008,7 @@
           <a:p>
             <a:fld id="{5BCAD085-E8A6-8845-BD4E-CB4CCA059FC4}" type="datetimeFigureOut">
               <a:rPr lang="en-US" smtClean="0"/>
-              <a:t>9/9/2026</a:t>
+              <a:t>9/10/2026</a:t>
             </a:fld>
             <a:endParaRPr lang="en-US"/>
           </a:p>
@@ -2283,7 +2283,7 @@
           <a:p>
             <a:fld id="{5BCAD085-E8A6-8845-BD4E-CB4CCA059FC4}" type="datetimeFigureOut">
               <a:rPr lang="en-US" smtClean="0"/>
-              <a:t>9/9/2026</a:t>
+              <a:t>9/10/2026</a:t>
             </a:fld>
             <a:endParaRPr lang="en-US"/>
           </a:p>
@@ -2535,7 +2535,7 @@
           <a:p>
             <a:fld id="{5BCAD085-E8A6-8845-BD4E-CB4CCA059FC4}" type="datetimeFigureOut">
               <a:rPr lang="en-US" smtClean="0"/>
-              <a:t>9/9/2026</a:t>
+              <a:t>9/10/2026</a:t>
             </a:fld>
             <a:endParaRPr lang="en-US"/>
           </a:p>
@@ -2746,7 +2746,7 @@
           <a:p>
             <a:fld id="{5BCAD085-E8A6-8845-BD4E-CB4CCA059FC4}" type="datetimeFigureOut">
               <a:rPr lang="en-US" smtClean="0"/>
-              <a:t>9/9/2026</a:t>
+              <a:t>9/10/2026</a:t>
             </a:fld>
             <a:endParaRPr lang="en-US"/>
           </a:p>
@@ -15474,30 +15474,6 @@
           </a:prstGeom>
         </p:spPr>
       </p:pic>
-      <p:pic>
-        <p:nvPicPr>
-          <p:cNvPr id="7" name="Picture 6" descr="eq_39bdac431bdbed96.png"/>
-          <p:cNvPicPr>
-            <a:picLocks noChangeAspect="1"/>
-          </p:cNvPicPr>
-          <p:nvPr/>
-        </p:nvPicPr>
-        <p:blipFill>
-          <a:blip r:embed="rId3"/>
-          <a:stretch>
-            <a:fillRect/>
-          </a:stretch>
-        </p:blipFill>
-        <p:spPr>
-          <a:xfrm>
-            <a:off x="777240" y="2423160"/>
-            <a:ext cx="6217920" cy="1151250"/>
-          </a:xfrm>
-          <a:prstGeom prst="rect">
-            <a:avLst/>
-          </a:prstGeom>
-        </p:spPr>
-      </p:pic>
       <p:sp>
         <p:nvSpPr>
           <p:cNvPr id="8" name="Rounded Rectangle 7"/>
@@ -15667,7 +15643,7 @@
           <p:nvPr/>
         </p:nvPicPr>
         <p:blipFill>
-          <a:blip r:embed="rId4"/>
+          <a:blip r:embed="rId3"/>
           <a:stretch>
             <a:fillRect/>
           </a:stretch>
@@ -15908,6 +15884,71 @@
                 <a:latin typeface="Arial"/>
               </a:rPr>
               <a:t>Oppenheim &amp; Schafer + Raschka</a:t>
+            </a:r>
+          </a:p>
+        </p:txBody>
+      </p:sp>
+      <p:pic>
+        <p:nvPicPr>
+          <p:cNvPr id="20" name="Picture 19">
+            <a:extLst>
+              <a:ext uri="{FF2B5EF4-FFF2-40B4-BE49-F238E27FC236}">
+                <a16:creationId xmlns:a16="http://schemas.microsoft.com/office/drawing/2014/main" id="{90373062-1294-CF8B-7F0B-E662DE431933}"/>
+              </a:ext>
+            </a:extLst>
+          </p:cNvPr>
+          <p:cNvPicPr>
+            <a:picLocks noChangeAspect="1"/>
+          </p:cNvPicPr>
+          <p:nvPr/>
+        </p:nvPicPr>
+        <p:blipFill>
+          <a:blip r:embed="rId4"/>
+          <a:stretch>
+            <a:fillRect/>
+          </a:stretch>
+        </p:blipFill>
+        <p:spPr>
+          <a:xfrm>
+            <a:off x="1343025" y="2668816"/>
+            <a:ext cx="4019550" cy="933450"/>
+          </a:xfrm>
+          <a:prstGeom prst="rect">
+            <a:avLst/>
+          </a:prstGeom>
+        </p:spPr>
+      </p:pic>
+      <p:sp>
+        <p:nvSpPr>
+          <p:cNvPr id="21" name="TextBox 20">
+            <a:extLst>
+              <a:ext uri="{FF2B5EF4-FFF2-40B4-BE49-F238E27FC236}">
+                <a16:creationId xmlns:a16="http://schemas.microsoft.com/office/drawing/2014/main" id="{CBF7B093-45DD-38F5-3056-9950C4F3C88B}"/>
+              </a:ext>
+            </a:extLst>
+          </p:cNvPr>
+          <p:cNvSpPr txBox="1"/>
+          <p:nvPr/>
+        </p:nvSpPr>
+        <p:spPr>
+          <a:xfrm>
+            <a:off x="1343025" y="3858334"/>
+            <a:ext cx="4486677" cy="369332"/>
+          </a:xfrm>
+          <a:prstGeom prst="rect">
+            <a:avLst/>
+          </a:prstGeom>
+          <a:noFill/>
+        </p:spPr>
+        <p:txBody>
+          <a:bodyPr wrap="none" rtlCol="0">
+            <a:spAutoFit/>
+          </a:bodyPr>
+          <a:lstStyle/>
+          <a:p>
+            <a:r>
+              <a:rPr lang="en-US" dirty="0"/>
+              <a:t>(Local-window correlation; no kernel reversal)</a:t>
             </a:r>
           </a:p>
         </p:txBody>
@@ -28609,8 +28650,8 @@
         </p:blipFill>
         <p:spPr>
           <a:xfrm>
-            <a:off x="731520" y="2423160"/>
-            <a:ext cx="6950503" cy="1354412"/>
+            <a:off x="731521" y="2423160"/>
+            <a:ext cx="6886708" cy="1354412"/>
           </a:xfrm>
           <a:prstGeom prst="rect">
             <a:avLst/>

</xml_diff>